<commit_message>
Enhance numbered architecture diagram, flowchart and update docx/pptx
</commit_message>
<xml_diff>
--- a/docs/Proposal_AI_Air_Doctor.pptx
+++ b/docs/Proposal_AI_Air_Doctor.pptx
@@ -3949,7 +3949,7 @@
         <p:spPr>
           <a:xfrm>
             <a:off x="1051560" y="1554480"/>
-            <a:ext cx="8888798" cy="4572000"/>
+            <a:ext cx="8723630" cy="4572000"/>
           </a:xfrm>
           <a:prstGeom prst="rect">
             <a:avLst/>
@@ -4296,7 +4296,7 @@
         <p:spPr>
           <a:xfrm>
             <a:off x="914400" y="1463040"/>
-            <a:ext cx="3579261" cy="4709160"/>
+            <a:ext cx="3815705" cy="4709160"/>
           </a:xfrm>
           <a:prstGeom prst="rect">
             <a:avLst/>

</xml_diff>

<commit_message>
Add team member info: 7115093066 Yang, 7115093063 Hsu, 7115064183 Hsieh, 7115064202 Tan
</commit_message>
<xml_diff>
--- a/docs/Proposal_AI_Air_Doctor.pptx
+++ b/docs/Proposal_AI_Air_Doctor.pptx
@@ -3583,7 +3583,7 @@
                 <a:ea typeface="Microsoft JhengHei"/>
                 <a:cs typeface="Microsoft JhengHei"/>
               </a:rPr>
-              <a:t>組員:________、________、________、________</a:t>
+              <a:t>組員: 楊禾睿 (7115093066)、徐崇皓 (7115093063)、謝秉樺 (7115064183)、譚人傑 (7115064202)</a:t>
             </a:r>
           </a:p>
           <a:p>
@@ -3604,7 +3604,7 @@
                 <a:ea typeface="Microsoft JhengHei"/>
                 <a:cs typeface="Microsoft JhengHei"/>
               </a:rPr>
-              <a:t>課程:IoT 智慧系統應用專題    指導老師:________</a:t>
+              <a:t>課程: 物聯網與智慧系統應用專題    指導老師: 授課教授</a:t>
             </a:r>
           </a:p>
         </p:txBody>

</xml_diff>

<commit_message>
Update exact student ID format: 7115093066_Yang, 7115093063_Hsu, 7115064183_Hsieh, 7115064202_Tan across all documents, docx and pptx
</commit_message>
<xml_diff>
--- a/docs/Proposal_AI_Air_Doctor.pptx
+++ b/docs/Proposal_AI_Air_Doctor.pptx
@@ -3553,7 +3553,7 @@
         <p:spPr>
           <a:xfrm>
             <a:off x="822960" y="5303520"/>
-            <a:ext cx="9144000" cy="731520"/>
+            <a:ext cx="10058400" cy="731520"/>
           </a:xfrm>
           <a:prstGeom prst="rect">
             <a:avLst/>
@@ -3583,7 +3583,7 @@
                 <a:ea typeface="Microsoft JhengHei"/>
                 <a:cs typeface="Microsoft JhengHei"/>
               </a:rPr>
-              <a:t>組員: 楊禾睿 (7115093066)、徐崇皓 (7115093063)、謝秉樺 (7115064183)、譚人傑 (7115064202)</a:t>
+              <a:t>組員: 7115093066_楊禾睿、7115093063_徐崇皓、7115064183_謝秉樺、7115064202_譚人傑</a:t>
             </a:r>
           </a:p>
           <a:p>

</xml_diff>